<commit_message>
Showcase images and decks rebuilt; port audit: docs round 2
Co-Authored-By: Claude Opus 5.5 <noreply@anthropic.com>
Claude-Session: https://claude.ai/code/session_01RqRvcKhNwRBFVENDzemeAT
</commit_message>
<xml_diff>
--- a/docs/showcase/grocery-strategy.pptx
+++ b/docs/showcase/grocery-strategy.pptx
@@ -7986,7 +7986,7 @@
           <a:spcPct val="20000"/>
         </a:spcBef>
         <a:buFont typeface="Arial"/>
-        <a:buChar char="–"/>
+        <a:buChar char="•"/>
         <a:defRPr sz="2800" kern="1200">
           <a:solidFill>
             <a:schemeClr val="tx1"/>
@@ -8016,7 +8016,7 @@
           <a:spcPct val="20000"/>
         </a:spcBef>
         <a:buFont typeface="Arial"/>
-        <a:buChar char="–"/>
+        <a:buChar char="•"/>
         <a:defRPr sz="2000" kern="1200">
           <a:solidFill>
             <a:schemeClr val="tx1"/>

</xml_diff>

<commit_message>
Showcase images and decks rebuilt; port audit: docs round 3
Co-Authored-By: Claude Opus 5.5 <noreply@anthropic.com>
Claude-Session: https://claude.ai/code/session_01RqRvcKhNwRBFVENDzemeAT
</commit_message>
<xml_diff>
--- a/docs/showcase/grocery-strategy.pptx
+++ b/docs/showcase/grocery-strategy.pptx
@@ -8749,7 +8749,7 @@
                 </a:solidFill>
                 <a:latin typeface="Georgia"/>
               </a:rPr>
-              <a:t>56%</a:t>
+              <a:t>92%</a:t>
             </a:r>
           </a:p>
         </p:txBody>
@@ -8795,7 +8795,7 @@
                 </a:solidFill>
                 <a:latin typeface="Arial"/>
               </a:rPr>
-              <a:t>of Brindle's store sales come from its 58</a:t>
+              <a:t>of Brindle's store sales come from its 154</a:t>
             </a:r>
             <a:br/>
             <a:r>
@@ -8805,7 +8805,7 @@
                 </a:solidFill>
                 <a:latin typeface="Arial"/>
               </a:rPr>
-              <a:t>superstores, against a 40% large-store share of</a:t>
+              <a:t>superstores and supermarkets, against a 40%</a:t>
             </a:r>
             <a:br/>
             <a:r>
@@ -8815,7 +8815,7 @@
                 </a:solidFill>
                 <a:latin typeface="Arial"/>
               </a:rPr>
-              <a:t>the market</a:t>
+              <a:t>large-store share of the market</a:t>
             </a:r>
           </a:p>
         </p:txBody>
@@ -18285,7 +18285,7 @@
                 </a:solidFill>
                 <a:latin typeface="Arial"/>
               </a:rPr>
-              <a:t>Half the gap is £1.1bn of sales</a:t>
+              <a:t>Half the gap is £1.0bn of sales</a:t>
             </a:r>
           </a:p>
           <a:p>
@@ -18318,7 +18318,7 @@
                 </a:solidFill>
                 <a:latin typeface="Arial"/>
               </a:rPr>
-              <a:t>£1.1bn, 28% of today's store sales.</a:t>
+              <a:t>£1.0bn, 27% of today's store sales.</a:t>
             </a:r>
           </a:p>
           <a:p>

</xml_diff>